<commit_message>
Add Emir Sakiev to the team on the slides and README
Co-Authored-By: Claude Opus 5.5 <noreply@anthropic.com>
</commit_message>
<xml_diff>
--- a/ToiPlan.pptx
+++ b/ToiPlan.pptx
@@ -123,12 +123,12 @@
   <p:extLst>
     <p:ext uri="{521415D9-36F7-43E2-AB2F-B90AF26B5E84}">
       <p14:sectionLst xmlns:p14="http://schemas.microsoft.com/office/powerpoint/2010/main">
-        <p14:section name="Intro" id="{2b0baa81-56ae-fa8e-9341-8a1cd049d1c6}">
+        <p14:section name="Intro" id="{ab00e021-859f-11a6-acdf-adb4ae9bdc04}">
           <p14:sldIdLst>
             <p14:sldId id="256"/>
           </p14:sldIdLst>
         </p14:section>
-        <p14:section name="i. Problem overview" id="{4fcde13f-b058-23ca-f05c-0981a6b86f55}">
+        <p14:section name="i. Problem overview" id="{d6dbe96b-7031-b8e5-95b3-010606167d5b}">
           <p14:sldIdLst>
             <p14:sldId id="257"/>
             <p14:sldId id="258"/>
@@ -136,7 +136,7 @@
             <p14:sldId id="260"/>
           </p14:sldIdLst>
         </p14:section>
-        <p14:section name="ii. Algorithm explained" id="{df6e25c7-9573-8260-8106-1064c6e6eca4}">
+        <p14:section name="ii. Algorithm explained" id="{a94544c0-a437-0d7e-a26c-e77c3da6e512}">
           <p14:sldIdLst>
             <p14:sldId id="261"/>
             <p14:sldId id="262"/>
@@ -147,7 +147,7 @@
             <p14:sldId id="267"/>
           </p14:sldIdLst>
         </p14:section>
-        <p14:section name="iii. Solution &amp; results" id="{67c70f76-173a-afdb-84f2-7b3ef81d83b3}">
+        <p14:section name="iii. Solution &amp; results" id="{6e6c14fd-929a-e6c2-537f-db7200fdbf56}">
           <p14:sldIdLst>
             <p14:sldId id="268"/>
             <p14:sldId id="269"/>
@@ -155,7 +155,7 @@
             <p14:sldId id="271"/>
           </p14:sldIdLst>
         </p14:section>
-        <p14:section name="Wrap-up" id="{931e0532-d4e9-39e9-6ad9-8de18dbbc98e}">
+        <p14:section name="Wrap-up" id="{e102a0de-7e77-679f-536e-ae0d6e940f45}">
           <p14:sldIdLst>
             <p14:sldId id="272"/>
           </p14:sldIdLst>
@@ -5740,7 +5740,7 @@
                   <a:schemeClr val="bg1"/>
                 </a:solidFill>
               </a:rPr>
-              <a:t>Asylbek Zhunusov  ·  Optimization with Metaheuristic Algorithms  ·  Friday, 30 October 2026</a:t>
+              <a:t>Asylbek Zhunusov &amp; Emir Sakiev  ·  Optimization with Metaheuristic Algorithms  ·  Friday, 30 October 2026</a:t>
             </a:r>
             <a:endParaRPr lang="en-US" sz="1800" dirty="0"/>
           </a:p>

</xml_diff>

<commit_message>
Add Aidar Nasirov to the team on the slides and README
Co-Authored-By: Claude Opus 5.5 <noreply@anthropic.com>
</commit_message>
<xml_diff>
--- a/ToiPlan.pptx
+++ b/ToiPlan.pptx
@@ -5740,7 +5740,22 @@
                   <a:schemeClr val="bg1"/>
                 </a:solidFill>
               </a:rPr>
-              <a:t>Asylbek Zhunusov &amp; Emir Sakiev  ·  Optimization with Metaheuristic Algorithms  ·  Friday, 30 October 2026</a:t>
+              <a:t>Asylbek Zhunusov, Emir Sakiev &amp; Aidar Nasirov</a:t>
+            </a:r>
+            <a:br>
+              <a:rPr lang="en-US" sz="1800" dirty="0">
+                <a:solidFill>
+                  <a:schemeClr val="bg1"/>
+                </a:solidFill>
+              </a:rPr>
+            </a:br>
+            <a:r>
+              <a:rPr lang="en-US" sz="1800" dirty="0">
+                <a:solidFill>
+                  <a:schemeClr val="bg1"/>
+                </a:solidFill>
+              </a:rPr>
+              <a:t>Optimization with Metaheuristic Algorithms  ·  Friday, 30 October 2026</a:t>
             </a:r>
             <a:endParaRPr lang="en-US" sz="1800" dirty="0"/>
           </a:p>

</xml_diff>